<commit_message>
docs: polish final slides and defense speeches
</commit_message>
<xml_diff>
--- a/slides/nstep_sac_template_style_deck_ru.pptx
+++ b/slides/nstep_sac_template_style_deck_ru.pptx
@@ -2163,6 +2163,10 @@
             <a:prstDash val="solid"/>
           </a:ln>
         </p:spPr>
+        <p:txBody>
+          <a:bodyPr/>
+          <a:p/>
+        </p:txBody>
       </p:sp>
       <p:sp>
         <p:nvSpPr>
@@ -2786,7 +2790,7 @@
                 <a:ea typeface="Arial" pitchFamily="34" charset="-122"/>
                 <a:cs typeface="Arial" pitchFamily="34" charset="-120"/>
               </a:rPr>
-              <a:t>764</a:t>
+              <a:t>764 / 833</a:t>
             </a:r>
             <a:endParaRPr lang="en-US" sz="3400" dirty="0"/>
           </a:p>
@@ -2830,7 +2834,7 @@
                 <a:ea typeface="Arial" pitchFamily="34" charset="-122"/>
                 <a:cs typeface="Arial" pitchFamily="34" charset="-120"/>
               </a:rPr>
-              <a:t>SAC n=5 final</a:t>
+              <a:t>SAC n=5 final / best</a:t>
             </a:r>
             <a:endParaRPr lang="en-US" sz="1250" dirty="0"/>
           </a:p>
@@ -3184,6 +3188,10 @@
             <a:prstDash val="solid"/>
           </a:ln>
         </p:spPr>
+        <p:txBody>
+          <a:bodyPr/>
+          <a:p/>
+        </p:txBody>
       </p:sp>
       <p:sp>
         <p:nvSpPr>
@@ -3223,7 +3231,7 @@
                 <a:ea typeface="Arial" pitchFamily="34" charset="-122"/>
                 <a:cs typeface="Arial" pitchFamily="34" charset="-120"/>
               </a:rPr>
-              <a:t>n=3 пересекает return ≥3000 раньше, чем n=1.</a:t>
+              <a:t>≥3000: n=3 at 45k, n=1 at 65k.</a:t>
             </a:r>
             <a:endParaRPr lang="en-US" sz="2000" dirty="0"/>
           </a:p>
@@ -3267,7 +3275,7 @@
                 <a:ea typeface="Arial" pitchFamily="34" charset="-122"/>
                 <a:cs typeface="Arial" pitchFamily="34" charset="-120"/>
               </a:rPr>
-              <a:t>n=1 остаётся сильным baseline.</a:t>
+              <a:t>≥4000: n=3 at 70k, n=1 at 100k.</a:t>
             </a:r>
             <a:endParaRPr lang="en-US" sz="2000" dirty="0"/>
           </a:p>
@@ -3311,7 +3319,7 @@
                 <a:ea typeface="Arial" pitchFamily="34" charset="-122"/>
                 <a:cs typeface="Arial" pitchFamily="34" charset="-120"/>
               </a:rPr>
-              <a:t>n=5 не выходит в high-return behavior.</a:t>
+              <a:t>n=5 не достигает этих порогов.</a:t>
             </a:r>
             <a:endParaRPr lang="en-US" sz="2000" dirty="0"/>
           </a:p>
@@ -3399,7 +3407,7 @@
                 <a:ea typeface="Arial" pitchFamily="34" charset="-122"/>
                 <a:cs typeface="Arial" pitchFamily="34" charset="-120"/>
               </a:rPr>
-              <a:t>Умеренный n-step credit assignment может помочь, но naive longer target может дестабилизировать off-policy SAC.</a:t>
+              <a:t>Вывод: horizon — stability parameter, не bigger-is-better.</a:t>
             </a:r>
             <a:endParaRPr lang="en-US" sz="1600" dirty="0"/>
           </a:p>
@@ -4313,7 +4321,7 @@
                 <a:ea typeface="Arial" pitchFamily="34" charset="-122"/>
                 <a:cs typeface="Arial" pitchFamily="34" charset="-120"/>
               </a:rPr>
-              <a:t>Вероятные</a:t>
+              <a:t>Backup:</a:t>
             </a:r>
             <a:endParaRPr lang="en-US" sz="4000" dirty="0"/>
           </a:p>
@@ -4623,7 +4631,7 @@
                 <a:ea typeface="Arial" pitchFamily="34" charset="-122"/>
                 <a:cs typeface="Arial" pitchFamily="34" charset="-120"/>
               </a:rPr>
-              <a:t>Нет universal claim. Только этот setting.</a:t>
+              <a:t>Нет. Только этот seed/settings.</a:t>
             </a:r>
             <a:endParaRPr lang="en-US" sz="1500" dirty="0"/>
           </a:p>
@@ -6072,6 +6080,10 @@
             <a:prstDash val="solid"/>
           </a:ln>
         </p:spPr>
+        <p:txBody>
+          <a:bodyPr/>
+          <a:p/>
+        </p:txBody>
       </p:sp>
       <p:sp>
         <p:nvSpPr>
@@ -6495,7 +6507,7 @@
                 <a:ea typeface="Arial" pitchFamily="34" charset="-122"/>
                 <a:cs typeface="Arial" pitchFamily="34" charset="-120"/>
               </a:rPr>
-              <a:t>Это не новая статья с алгоритмом, а маленькая проверка центрального механизма.</a:t>
+              <a:t>Карта идей, не хронология: baseline → target horizon → correction/context.</a:t>
             </a:r>
             <a:endParaRPr lang="en-US" sz="1400" dirty="0"/>
           </a:p>
@@ -7191,7 +7203,7 @@
                 <a:ea typeface="Arial" pitchFamily="34" charset="-122"/>
                 <a:cs typeface="Arial" pitchFamily="34" charset="-120"/>
               </a:rPr>
-              <a:t>Этот проект: small-compute ablation naive n-step SAC</a:t>
+              <a:t>Этот проект: isolated ablation of target horizon</a:t>
             </a:r>
             <a:endParaRPr lang="en-US" sz="2300" dirty="0"/>
           </a:p>
@@ -7235,7 +7247,7 @@
                 <a:ea typeface="Arial" pitchFamily="34" charset="-122"/>
                 <a:cs typeface="Arial" pitchFamily="34" charset="-120"/>
               </a:rPr>
-              <a:t>SAC n=1 vs n=3 vs n=5, одинаковые гиперпараметры, один seed.</a:t>
+              <a:t>SAC n=1 vs n=3 vs n=5; меняется только horizon.</a:t>
             </a:r>
             <a:endParaRPr lang="en-US" sz="1500" dirty="0"/>
           </a:p>
@@ -7985,7 +7997,7 @@
                 <a:ea typeface="Arial" pitchFamily="34" charset="-122"/>
                 <a:cs typeface="Arial" pitchFamily="34" charset="-120"/>
               </a:rPr>
-              <a:t>SAC update тот же, меняется critic target.</a:t>
+              <a:t>Упрощённая TD-интуиция; soft SAC target — на следующем слайде.</a:t>
             </a:r>
             <a:endParaRPr lang="en-US" sz="1400" dirty="0"/>
           </a:p>
@@ -8781,6 +8793,10 @@
             <a:prstDash val="solid"/>
           </a:ln>
         </p:spPr>
+        <p:txBody>
+          <a:bodyPr/>
+          <a:p/>
+        </p:txBody>
       </p:sp>
       <p:sp>
         <p:nvSpPr>
@@ -9131,7 +9147,7 @@
                 <a:ea typeface="Arial" pitchFamily="34" charset="-122"/>
                 <a:cs typeface="Arial" pitchFamily="34" charset="-120"/>
               </a:rPr>
-              <a:t>Это компактная реализация для ablation, не полная SACn/T-SAC reproduction.</a:t>
+              <a:t>Цель: чистая ablation target horizon, без полной SACn/T-SAC reproduction.</a:t>
             </a:r>
             <a:endParaRPr lang="en-US" sz="1400" dirty="0"/>
           </a:p>

</xml_diff>